<commit_message>
new file:   "\347\273\204\345\206\205\346\210\220\345\221\230\350\241\250.xlsx" 	modified:   "\347\276\216\346\234\257\345\260\217\347\273\20420260911\345\215\203\345\271\264\345\234\237\345\234\260\347\277\273\344\272\206\350\272\253.pptx"
</commit_message>
<xml_diff>
--- a/美术小组20260911千年土地翻了身.pptx
+++ b/美术小组20260911千年土地翻了身.pptx
@@ -107,6 +107,11 @@
       </a:defRPr>
     </a:lvl9pPr>
   </p:defaultTextStyle>
+  <p:extLst>
+    <p:ext uri="{EFAFB233-063F-42B5-8137-9DF3F51BA10A}">
+      <p15:sldGuideLst xmlns:p15="http://schemas.microsoft.com/office/powerpoint/2012/main"/>
+    </p:ext>
+  </p:extLst>
 </p:presentation>
 </file>
 
@@ -3360,6 +3365,102 @@
           </a:prstGeom>
         </p:spPr>
       </p:pic>
+      <p:sp>
+        <p:nvSpPr>
+          <p:cNvPr id="5" name="文本框 4">
+            <a:extLst>
+              <a:ext uri="{FF2B5EF4-FFF2-40B4-BE49-F238E27FC236}">
+                <a16:creationId xmlns:a16="http://schemas.microsoft.com/office/drawing/2014/main" id="{821492F8-6AA1-D18F-8F82-A88EB1720CCC}"/>
+              </a:ext>
+            </a:extLst>
+          </p:cNvPr>
+          <p:cNvSpPr txBox="1"/>
+          <p:nvPr/>
+        </p:nvSpPr>
+        <p:spPr>
+          <a:xfrm>
+            <a:off x="583008" y="3768064"/>
+            <a:ext cx="10463436" cy="2308324"/>
+          </a:xfrm>
+          <a:prstGeom prst="rect">
+            <a:avLst/>
+          </a:prstGeom>
+          <a:noFill/>
+        </p:spPr>
+        <p:txBody>
+          <a:bodyPr wrap="square" rtlCol="0">
+            <a:spAutoFit/>
+          </a:bodyPr>
+          <a:lstStyle/>
+          <a:p>
+            <a:r>
+              <a:rPr lang="zh-CN" altLang="zh-CN" sz="2400" dirty="0"/>
+              <a:t>这幅画代表新中国美术发展。董希文三进西藏写生，积累素材。他以朴素画风表现西藏农奴翻身做主，在土地上耕耘的喜悦。</a:t>
+            </a:r>
+          </a:p>
+          <a:p>
+            <a:r>
+              <a:rPr lang="zh-CN" altLang="zh-CN" sz="2400" dirty="0"/>
+              <a:t>画面充满动感。人物后仰，牦牛奋蹄，笔触方向一致。雪山蓝天带来不一样的春天。</a:t>
+            </a:r>
+          </a:p>
+          <a:p>
+            <a:r>
+              <a:rPr lang="zh-CN" altLang="zh-CN" sz="2400" dirty="0"/>
+              <a:t>对角线构图和桃红上衣与左下阴影对比。这表现出高原阳光，也表现出人物内心的激动喜悦。</a:t>
+            </a:r>
+          </a:p>
+        </p:txBody>
+      </p:sp>
+      <p:sp>
+        <p:nvSpPr>
+          <p:cNvPr id="6" name="文本框 5">
+            <a:extLst>
+              <a:ext uri="{FF2B5EF4-FFF2-40B4-BE49-F238E27FC236}">
+                <a16:creationId xmlns:a16="http://schemas.microsoft.com/office/drawing/2014/main" id="{8A55A1E2-AE62-3EE2-1327-0CF927CE7833}"/>
+              </a:ext>
+            </a:extLst>
+          </p:cNvPr>
+          <p:cNvSpPr txBox="1"/>
+          <p:nvPr/>
+        </p:nvSpPr>
+        <p:spPr>
+          <a:xfrm>
+            <a:off x="441859" y="997393"/>
+            <a:ext cx="5512992" cy="2123658"/>
+          </a:xfrm>
+          <a:prstGeom prst="rect">
+            <a:avLst/>
+          </a:prstGeom>
+          <a:noFill/>
+        </p:spPr>
+        <p:txBody>
+          <a:bodyPr wrap="square" rtlCol="0">
+            <a:spAutoFit/>
+          </a:bodyPr>
+          <a:lstStyle/>
+          <a:p>
+            <a:r>
+              <a:rPr lang="en-US" altLang="zh-CN" sz="3600" dirty="0"/>
+              <a:t>《</a:t>
+            </a:r>
+            <a:r>
+              <a:rPr lang="zh-CN" altLang="zh-CN" sz="3600" dirty="0"/>
+              <a:t>千年土地翻了身》</a:t>
+            </a:r>
+            <a:endParaRPr lang="en-US" altLang="zh-CN" sz="3600" dirty="0"/>
+          </a:p>
+          <a:p>
+            <a:r>
+              <a:rPr lang="zh-CN" altLang="zh-CN" sz="3200" dirty="0"/>
+              <a:t>是董希文1963年油画，藏中国美术馆。</a:t>
+            </a:r>
+          </a:p>
+          <a:p>
+            <a:endParaRPr lang="zh-CN" altLang="en-US" sz="3200" dirty="0"/>
+          </a:p>
+        </p:txBody>
+      </p:sp>
     </p:spTree>
     <p:extLst>
       <p:ext uri="{BB962C8B-B14F-4D97-AF65-F5344CB8AC3E}">

</xml_diff>